<commit_message>
Improve saliency model results
</commit_message>
<xml_diff>
--- a/artifacts/presentation_slides.pptx
+++ b/artifacts/presentation_slides.pptx
@@ -1525,7 +1525,7 @@
                   <a:srgbClr val="1F2937"/>
                 </a:solidFill>
               </a:rPr>
-              <a:t>Balanced mode: IoU 0.5364, F1 0.6915, recall 0.7711</a:t>
+              <a:t>Best balanced: IoU 0.5956, F1 0.7394, recall 0.8203</a:t>
             </a:r>
           </a:p>
         </p:txBody>
@@ -1583,7 +1583,7 @@
                   <a:srgbClr val="1F2937"/>
                 </a:solidFill>
               </a:rPr>
-              <a:t>High-precision mode: precision 0.8726 at threshold 0.94</a:t>
+              <a:t>High-precision mode: precision 0.8711 at threshold 0.91</a:t>
             </a:r>
           </a:p>
         </p:txBody>
@@ -1641,7 +1641,7 @@
                   <a:srgbClr val="1F2937"/>
                 </a:solidFill>
               </a:rPr>
-              <a:t>Baseline F1 improved from 0.6278 to 0.6915</a:t>
+              <a:t>Baseline F1 improved from 0.6278 to 0.7394</a:t>
             </a:r>
           </a:p>
         </p:txBody>
@@ -1699,7 +1699,7 @@
                   <a:srgbClr val="1F2937"/>
                 </a:solidFill>
               </a:rPr>
-              <a:t>Logs, checkpoints, metrics, and visual grids are saved</a:t>
+              <a:t>Fine-tuned with BCE + Dice + IoU loss</a:t>
             </a:r>
           </a:p>
         </p:txBody>

</xml_diff>